<commit_message>
Rework Power BI report and pitch deck per review comments
- Power BI: pie of revenue movement on Overview, % on chart labels,
  figures in thousands ($183K, not $0.2M), and the revenue bridge as
  stacked columns so revenue carried forward fills the space under
  each driver bar (new BridgeChart table).
- Deck slide 3: filled waterfall, increases vs decreases, key vs
  non-key drivers (Pareto 80%).
- Deck slide 4: driver chart (favourable vs unfavourable) and key vs
  non-key pie in place of the table; revenue and cost drivers split.
- Deck slide 6: findings, risks, recommendations in three columns;
  figure-based risks and recommendations, duplicate caveats removed.
- Dashboard waterfall and PDF export: carried-forward fill.

Co-Authored-By: Claude Opus 5.5 <noreply@anthropic.com>
</commit_message>
<xml_diff>
--- a/tmp/deck/dark.pptx
+++ b/tmp/deck/dark.pptx
@@ -151,16 +151,16 @@
                   <c:v>2026-07</c:v>
                 </c:pt>
                 <c:pt idx="1">
-                  <c:v>Meridian Health</c:v>
+                  <c:v>Meridian Health (+6.7%)</c:v>
                 </c:pt>
                 <c:pt idx="2">
-                  <c:v>SMB Bulk (aggregated)</c:v>
+                  <c:v>SMB Bulk (aggregated) (+6.0%)</c:v>
                 </c:pt>
                 <c:pt idx="3">
-                  <c:v>Northwind Labs</c:v>
+                  <c:v>Northwind Labs (+5.3%)</c:v>
                 </c:pt>
                 <c:pt idx="4">
-                  <c:v>AtlasGrid</c:v>
+                  <c:v>AtlasGrid (+4.0%)</c:v>
                 </c:pt>
                 <c:pt idx="5">
                   <c:v>2026-08</c:v>
@@ -210,7 +210,7 @@
             </a:solidFill>
           </c:spPr>
           <c:dLbls>
-            <c:numFmt formatCode="$#,##0;-$#,##0;;" sourceLinked="0"/>
+            <c:numFmt formatCode="[&gt;=10000]$#,##0,&quot;K&quot;;$#,##0.0,&quot;K&quot;" sourceLinked="0"/>
             <c:txPr>
               <a:bodyPr/>
               <a:lstStyle/>
@@ -242,16 +242,16 @@
                   <c:v>2026-07</c:v>
                 </c:pt>
                 <c:pt idx="1">
-                  <c:v>Meridian Health</c:v>
+                  <c:v>Meridian Health (+6.7%)</c:v>
                 </c:pt>
                 <c:pt idx="2">
-                  <c:v>SMB Bulk (aggregated)</c:v>
+                  <c:v>SMB Bulk (aggregated) (+6.0%)</c:v>
                 </c:pt>
                 <c:pt idx="3">
-                  <c:v>Northwind Labs</c:v>
+                  <c:v>Northwind Labs (+5.3%)</c:v>
                 </c:pt>
                 <c:pt idx="4">
-                  <c:v>AtlasGrid</c:v>
+                  <c:v>AtlasGrid (+4.0%)</c:v>
                 </c:pt>
                 <c:pt idx="5">
                   <c:v>2026-08</c:v>
@@ -295,7 +295,7 @@
             </a:solidFill>
           </c:spPr>
           <c:dLbls>
-            <c:numFmt formatCode="$#,##0;-$#,##0;;" sourceLinked="0"/>
+            <c:numFmt formatCode="[&gt;=10000]$#,##0,&quot;K&quot;;$#,##0.0,&quot;K&quot;" sourceLinked="0"/>
             <c:txPr>
               <a:bodyPr/>
               <a:lstStyle/>
@@ -327,16 +327,16 @@
                   <c:v>2026-07</c:v>
                 </c:pt>
                 <c:pt idx="1">
-                  <c:v>Meridian Health</c:v>
+                  <c:v>Meridian Health (+6.7%)</c:v>
                 </c:pt>
                 <c:pt idx="2">
-                  <c:v>SMB Bulk (aggregated)</c:v>
+                  <c:v>SMB Bulk (aggregated) (+6.0%)</c:v>
                 </c:pt>
                 <c:pt idx="3">
-                  <c:v>Northwind Labs</c:v>
+                  <c:v>Northwind Labs (+5.3%)</c:v>
                 </c:pt>
                 <c:pt idx="4">
-                  <c:v>AtlasGrid</c:v>
+                  <c:v>AtlasGrid (+4.0%)</c:v>
                 </c:pt>
                 <c:pt idx="5">
                   <c:v>2026-08</c:v>
@@ -386,7 +386,7 @@
             </a:solidFill>
           </c:spPr>
           <c:dLbls>
-            <c:numFmt formatCode="$#,##0;-$#,##0;;" sourceLinked="0"/>
+            <c:numFmt formatCode="[&gt;=10000]$#,##0,&quot;K&quot;;$#,##0.0,&quot;K&quot;" sourceLinked="0"/>
             <c:txPr>
               <a:bodyPr/>
               <a:lstStyle/>
@@ -418,16 +418,16 @@
                   <c:v>2026-07</c:v>
                 </c:pt>
                 <c:pt idx="1">
-                  <c:v>Meridian Health</c:v>
+                  <c:v>Meridian Health (+6.7%)</c:v>
                 </c:pt>
                 <c:pt idx="2">
-                  <c:v>SMB Bulk (aggregated)</c:v>
+                  <c:v>SMB Bulk (aggregated) (+6.0%)</c:v>
                 </c:pt>
                 <c:pt idx="3">
-                  <c:v>Northwind Labs</c:v>
+                  <c:v>Northwind Labs (+5.3%)</c:v>
                 </c:pt>
                 <c:pt idx="4">
-                  <c:v>AtlasGrid</c:v>
+                  <c:v>AtlasGrid (+4.0%)</c:v>
                 </c:pt>
                 <c:pt idx="5">
                   <c:v>2026-08</c:v>
@@ -503,7 +503,7 @@
             </a:ln>
           </c:spPr>
         </c:majorGridlines>
-        <c:numFmt formatCode="$#,##0" sourceLinked="0"/>
+        <c:numFmt formatCode="$#,##0,&quot;K&quot;" sourceLinked="0"/>
         <c:majorTickMark val="out"/>
         <c:minorTickMark val="none"/>
         <c:tickLblPos val="nextTo"/>
@@ -553,6 +553,187 @@
 </file>
 
 <file path=ppt/charts/chart2.xml><?xml version="1.0" encoding="utf-8"?>
+<c:chartSpace xmlns:c="http://schemas.openxmlformats.org/drawingml/2006/chart" xmlns:a="http://schemas.openxmlformats.org/drawingml/2006/main" xmlns:r="http://schemas.openxmlformats.org/officeDocument/2006/relationships">
+  <c:chart>
+    <c:autoTitleDeleted val="1"/>
+    <c:plotArea>
+      <c:pieChart>
+        <c:varyColors val="1"/>
+        <c:ser>
+          <c:idx val="0"/>
+          <c:order val="0"/>
+          <c:tx>
+            <c:strRef>
+              <c:f>Sheet1!$B$1</c:f>
+              <c:strCache>
+                <c:ptCount val="1"/>
+                <c:pt idx="0">
+                  <c:v>Share of movement</c:v>
+                </c:pt>
+              </c:strCache>
+            </c:strRef>
+          </c:tx>
+          <c:dPt>
+            <c:idx val="0"/>
+            <c:spPr>
+              <a:solidFill>
+                <a:srgbClr val="5B9BD5"/>
+              </a:solidFill>
+              <a:ln>
+                <a:solidFill>
+                  <a:srgbClr val="16212E"/>
+                </a:solidFill>
+              </a:ln>
+            </c:spPr>
+          </c:dPt>
+          <c:dPt>
+            <c:idx val="1"/>
+            <c:spPr>
+              <a:solidFill>
+                <a:srgbClr val="2BB3A3"/>
+              </a:solidFill>
+              <a:ln>
+                <a:solidFill>
+                  <a:srgbClr val="16212E"/>
+                </a:solidFill>
+              </a:ln>
+            </c:spPr>
+          </c:dPt>
+          <c:dPt>
+            <c:idx val="2"/>
+            <c:spPr>
+              <a:solidFill>
+                <a:srgbClr val="F2C14E"/>
+              </a:solidFill>
+              <a:ln>
+                <a:solidFill>
+                  <a:srgbClr val="16212E"/>
+                </a:solidFill>
+              </a:ln>
+            </c:spPr>
+          </c:dPt>
+          <c:dPt>
+            <c:idx val="3"/>
+            <c:spPr>
+              <a:solidFill>
+                <a:srgbClr val="A5B4C8"/>
+              </a:solidFill>
+              <a:ln>
+                <a:solidFill>
+                  <a:srgbClr val="16212E"/>
+                </a:solidFill>
+              </a:ln>
+            </c:spPr>
+          </c:dPt>
+          <c:cat>
+            <c:strRef>
+              <c:f>Sheet1!$A$2:$A$5</c:f>
+              <c:strCache>
+                <c:ptCount val="4"/>
+                <c:pt idx="0">
+                  <c:v>Meridian Health</c:v>
+                </c:pt>
+                <c:pt idx="1">
+                  <c:v>SMB Bulk (aggregated)</c:v>
+                </c:pt>
+                <c:pt idx="2">
+                  <c:v>Northwind Labs</c:v>
+                </c:pt>
+                <c:pt idx="3">
+                  <c:v>AtlasGrid</c:v>
+                </c:pt>
+              </c:strCache>
+            </c:strRef>
+          </c:cat>
+          <c:val>
+            <c:numRef>
+              <c:f>Sheet1!$B$2:$B$5</c:f>
+              <c:numCache>
+                <c:formatCode>General</c:formatCode>
+                <c:ptCount val="4"/>
+                <c:pt idx="0">
+                  <c:v>10000.0</c:v>
+                </c:pt>
+                <c:pt idx="1">
+                  <c:v>9000.0</c:v>
+                </c:pt>
+                <c:pt idx="2">
+                  <c:v>8000.0</c:v>
+                </c:pt>
+                <c:pt idx="3">
+                  <c:v>6000.0</c:v>
+                </c:pt>
+              </c:numCache>
+            </c:numRef>
+          </c:val>
+        </c:ser>
+        <c:dLbls>
+          <c:numFmt formatCode="0.0%" sourceLinked="0"/>
+          <c:txPr>
+            <a:bodyPr/>
+            <a:lstStyle/>
+            <a:p>
+              <a:pPr>
+                <a:defRPr sz="1000" b="1">
+                  <a:solidFill>
+                    <a:srgbClr val="FFFFFF"/>
+                  </a:solidFill>
+                </a:defRPr>
+              </a:pPr>
+            </a:p>
+          </c:txPr>
+          <c:dLblPos val="bestFit"/>
+          <c:showLegendKey val="0"/>
+          <c:showVal val="0"/>
+          <c:showCatName val="0"/>
+          <c:showSerName val="0"/>
+          <c:showPercent val="1"/>
+          <c:showBubbleSize val="0"/>
+          <c:showLeaderLines val="1"/>
+        </c:dLbls>
+      </c:pieChart>
+    </c:plotArea>
+    <c:legend>
+      <c:legendPos val="b"/>
+      <c:overlay val="0"/>
+      <c:txPr>
+        <a:bodyPr/>
+        <a:lstStyle/>
+        <a:p>
+          <a:pPr>
+            <a:defRPr sz="900">
+              <a:solidFill>
+                <a:srgbClr val="E6EDF5"/>
+              </a:solidFill>
+            </a:defRPr>
+          </a:pPr>
+        </a:p>
+      </c:txPr>
+    </c:legend>
+    <c:dispBlanksAs val="gap"/>
+  </c:chart>
+  <c:txPr>
+    <a:bodyPr/>
+    <a:lstStyle/>
+    <a:p>
+      <a:pPr>
+        <a:defRPr sz="1000">
+          <a:solidFill>
+            <a:srgbClr val="9AA8B8"/>
+          </a:solidFill>
+          <a:latin typeface="Calibri"/>
+        </a:defRPr>
+      </a:pPr>
+      <a:endParaRPr lang="en-US"/>
+    </a:p>
+  </c:txPr>
+  <c:externalData r:id="rId1">
+    <c:autoUpdate val="0"/>
+  </c:externalData>
+</c:chartSpace>
+</file>
+
+<file path=ppt/charts/chart3.xml><?xml version="1.0" encoding="utf-8"?>
 <c:chartSpace xmlns:c="http://schemas.openxmlformats.org/drawingml/2006/chart" xmlns:a="http://schemas.openxmlformats.org/drawingml/2006/main" xmlns:r="http://schemas.openxmlformats.org/officeDocument/2006/relationships">
   <c:date1904 val="0"/>
   <c:chart>
@@ -617,23 +798,153 @@
             </c:spPr>
           </c:dPt>
           <c:dLbls>
-            <c:numFmt formatCode="$#,##0;-$#,##0" sourceLinked="0"/>
-            <c:txPr>
-              <a:bodyPr/>
-              <a:lstStyle/>
-              <a:p>
-                <a:pPr>
-                  <a:defRPr sz="1000" b="1">
-                    <a:solidFill>
-                      <a:srgbClr val="E6EDF5"/>
-                    </a:solidFill>
-                  </a:defRPr>
-                </a:pPr>
-              </a:p>
-            </c:txPr>
-            <c:dLblPos val="outEnd"/>
+            <c:dLbl>
+              <c:idx val="0"/>
+              <c:tx>
+                <c:rich>
+                  <a:bodyPr/>
+                  <a:lstStyle/>
+                  <a:p>
+                    <a:pPr>
+                      <a:defRPr/>
+                    </a:pPr>
+                    <a:r>
+                      <a:rPr sz="1000" b="1">
+                        <a:solidFill>
+                          <a:srgbClr val="E6EDF5"/>
+                        </a:solidFill>
+                      </a:rPr>
+                      <a:t>+$10K</a:t>
+                    </a:r>
+                  </a:p>
+                </c:rich>
+              </c:tx>
+              <c:dLblPos val="outEnd"/>
+              <c:showLegendKey val="0"/>
+              <c:showVal val="1"/>
+              <c:showCatName val="0"/>
+              <c:showSerName val="0"/>
+              <c:showPercent val="0"/>
+              <c:showBubbleSize val="0"/>
+            </c:dLbl>
+            <c:dLbl>
+              <c:idx val="1"/>
+              <c:tx>
+                <c:rich>
+                  <a:bodyPr/>
+                  <a:lstStyle/>
+                  <a:p>
+                    <a:pPr>
+                      <a:defRPr/>
+                    </a:pPr>
+                    <a:r>
+                      <a:rPr sz="1000" b="1">
+                        <a:solidFill>
+                          <a:srgbClr val="E6EDF5"/>
+                        </a:solidFill>
+                      </a:rPr>
+                      <a:t>+$9.0K</a:t>
+                    </a:r>
+                  </a:p>
+                </c:rich>
+              </c:tx>
+              <c:dLblPos val="outEnd"/>
+              <c:showLegendKey val="0"/>
+              <c:showVal val="1"/>
+              <c:showCatName val="0"/>
+              <c:showSerName val="0"/>
+              <c:showPercent val="0"/>
+              <c:showBubbleSize val="0"/>
+            </c:dLbl>
+            <c:dLbl>
+              <c:idx val="2"/>
+              <c:tx>
+                <c:rich>
+                  <a:bodyPr/>
+                  <a:lstStyle/>
+                  <a:p>
+                    <a:pPr>
+                      <a:defRPr/>
+                    </a:pPr>
+                    <a:r>
+                      <a:rPr sz="1000" b="1">
+                        <a:solidFill>
+                          <a:srgbClr val="E6EDF5"/>
+                        </a:solidFill>
+                      </a:rPr>
+                      <a:t>+$8.0K</a:t>
+                    </a:r>
+                  </a:p>
+                </c:rich>
+              </c:tx>
+              <c:dLblPos val="outEnd"/>
+              <c:showLegendKey val="0"/>
+              <c:showVal val="1"/>
+              <c:showCatName val="0"/>
+              <c:showSerName val="0"/>
+              <c:showPercent val="0"/>
+              <c:showBubbleSize val="0"/>
+            </c:dLbl>
+            <c:dLbl>
+              <c:idx val="3"/>
+              <c:tx>
+                <c:rich>
+                  <a:bodyPr/>
+                  <a:lstStyle/>
+                  <a:p>
+                    <a:pPr>
+                      <a:defRPr/>
+                    </a:pPr>
+                    <a:r>
+                      <a:rPr sz="1000" b="1">
+                        <a:solidFill>
+                          <a:srgbClr val="E6EDF5"/>
+                        </a:solidFill>
+                      </a:rPr>
+                      <a:t>+$6.4K</a:t>
+                    </a:r>
+                  </a:p>
+                </c:rich>
+              </c:tx>
+              <c:dLblPos val="outEnd"/>
+              <c:showLegendKey val="0"/>
+              <c:showVal val="1"/>
+              <c:showCatName val="0"/>
+              <c:showSerName val="0"/>
+              <c:showPercent val="0"/>
+              <c:showBubbleSize val="0"/>
+            </c:dLbl>
+            <c:dLbl>
+              <c:idx val="4"/>
+              <c:tx>
+                <c:rich>
+                  <a:bodyPr/>
+                  <a:lstStyle/>
+                  <a:p>
+                    <a:pPr>
+                      <a:defRPr/>
+                    </a:pPr>
+                    <a:r>
+                      <a:rPr sz="1000" b="1">
+                        <a:solidFill>
+                          <a:srgbClr val="E6EDF5"/>
+                        </a:solidFill>
+                      </a:rPr>
+                      <a:t>+$6.0K</a:t>
+                    </a:r>
+                  </a:p>
+                </c:rich>
+              </c:tx>
+              <c:dLblPos val="outEnd"/>
+              <c:showLegendKey val="0"/>
+              <c:showVal val="1"/>
+              <c:showCatName val="0"/>
+              <c:showSerName val="0"/>
+              <c:showPercent val="0"/>
+              <c:showBubbleSize val="0"/>
+            </c:dLbl>
             <c:showLegendKey val="0"/>
-            <c:showVal val="1"/>
+            <c:showVal val="0"/>
             <c:showCatName val="0"/>
             <c:showSerName val="0"/>
             <c:showPercent val="0"/>
@@ -646,19 +957,19 @@
               <c:strCache>
                 <c:ptCount val="5"/>
                 <c:pt idx="0">
-                  <c:v>Meridian Health</c:v>
+                  <c:v>Meridian Health (new)</c:v>
                 </c:pt>
                 <c:pt idx="1">
-                  <c:v>SMB Bulk (aggregated)</c:v>
+                  <c:v>SMB Bulk (aggregated) (+6.8%)</c:v>
                 </c:pt>
                 <c:pt idx="2">
-                  <c:v>Northwind Labs</c:v>
+                  <c:v>Northwind Labs (+80.0%)</c:v>
                 </c:pt>
                 <c:pt idx="3">
-                  <c:v>AWS</c:v>
+                  <c:v>AWS (+22.0%)</c:v>
                 </c:pt>
                 <c:pt idx="4">
-                  <c:v>AtlasGrid</c:v>
+                  <c:v>AtlasGrid (+75.0%)</c:v>
                 </c:pt>
               </c:strCache>
             </c:strRef>
@@ -731,10 +1042,12 @@
       </c:catAx>
       <c:valAx>
         <c:axId val="-2113994440"/>
-        <c:scaling/>
+        <c:scaling>
+          <c:max val="13000.0"/>
+        </c:scaling>
         <c:delete/>
         <c:axPos val="b"/>
-        <c:numFmt formatCode="$#,##0;-$#,##0" sourceLinked="0"/>
+        <c:numFmt formatCode="$#,##0,&quot;K&quot;" sourceLinked="0"/>
         <c:majorTickMark val="out"/>
         <c:minorTickMark val="none"/>
         <c:tickLblPos val="nextTo"/>
@@ -783,7 +1096,7 @@
 </c:chartSpace>
 </file>
 
-<file path=ppt/charts/chart3.xml><?xml version="1.0" encoding="utf-8"?>
+<file path=ppt/charts/chart4.xml><?xml version="1.0" encoding="utf-8"?>
 <c:chartSpace xmlns:c="http://schemas.openxmlformats.org/drawingml/2006/chart" xmlns:a="http://schemas.openxmlformats.org/drawingml/2006/main" xmlns:r="http://schemas.openxmlformats.org/officeDocument/2006/relationships">
   <c:date1904 val="0"/>
   <c:chart>
@@ -880,34 +1193,34 @@
                 <c:formatCode>General</c:formatCode>
                 <c:ptCount val="10"/>
                 <c:pt idx="0">
-                  <c:v>26</c:v>
+                  <c:v>17</c:v>
                 </c:pt>
                 <c:pt idx="1">
-                  <c:v>15</c:v>
+                  <c:v>10</c:v>
                 </c:pt>
                 <c:pt idx="2">
-                  <c:v>12</c:v>
+                  <c:v>5</c:v>
                 </c:pt>
                 <c:pt idx="3">
-                  <c:v>8</c:v>
+                  <c:v>2</c:v>
                 </c:pt>
                 <c:pt idx="4">
-                  <c:v>11</c:v>
+                  <c:v>672</c:v>
                 </c:pt>
                 <c:pt idx="5">
-                  <c:v>5621</c:v>
+                  <c:v>7044</c:v>
                 </c:pt>
                 <c:pt idx="6">
-                  <c:v>8965</c:v>
+                  <c:v>7932</c:v>
                 </c:pt>
                 <c:pt idx="7">
-                  <c:v>0</c:v>
+                  <c:v>1</c:v>
                 </c:pt>
                 <c:pt idx="8">
-                  <c:v>3379</c:v>
+                  <c:v>2176</c:v>
                 </c:pt>
                 <c:pt idx="9">
-                  <c:v>77</c:v>
+                  <c:v>272</c:v>
                 </c:pt>
               </c:numCache>
             </c:numRef>
@@ -957,7 +1270,7 @@
       <c:valAx>
         <c:axId val="-2113994440"/>
         <c:scaling>
-          <c:max val="11206.25"/>
+          <c:max val="9915.0"/>
         </c:scaling>
         <c:delete/>
         <c:axPos val="b"/>
@@ -1405,7 +1718,7 @@
           <a:lstStyle/>
           <a:p>
             <a:r>
-              <a:t>Opening. Subscription revenue jumped $33K MoM, driven by four key accounts; cloud hosting costs rose $6.4K due to AWS. Revenue moved from $150K to $183K. The rest of the deck explains why, how sure we are, and what we do next.</a:t>
+              <a:t>Opening. Subscription revenue up $33K (22%) and cloud hosting expense up $6.4K (22%) in August Revenue moved from $150K to $183K. The rest of the deck explains why, how sure we are, and what we do next.</a:t>
             </a:r>
           </a:p>
         </p:txBody>
@@ -1545,7 +1858,7 @@
           <a:lstStyle/>
           <a:p>
             <a:r>
-              <a:t>Walk the chart left to right: opening revenue, each driver's contribution, closing revenue. Green bars add revenue, red bars subtract. The bars tie exactly to both endpoints.</a:t>
+              <a:t>Walk the chart left to right: opening revenue, each driver's contribution, closing revenue. Green bars add revenue, red bars subtract. The bars tie exactly to both endpoints. The pie shows how the total movement splits across drivers. Drivers fully explain the movement; no unattributed remainder.</a:t>
             </a:r>
           </a:p>
         </p:txBody>
@@ -1685,7 +1998,7 @@
           <a:lstStyle/>
           <a:p>
             <a:r>
-              <a:t>Assurance. 10/10 numbers verified. Data quality 100%, overall confidence 88%. This is the answer to 'can I trust this?'.</a:t>
+              <a:t>Assurance. 16/16 numbers verified. Data quality 100%, overall confidence 88%. This is the answer to 'can I trust this?'.</a:t>
             </a:r>
           </a:p>
         </p:txBody>
@@ -1755,13 +2068,13 @@
           <a:lstStyle/>
           <a:p>
             <a:r>
-              <a:t>DemoCo's subscription revenue rose $33K MoM to $183K, driven by four key accounts (Meridian Health $10K, SMB Bulk $9K, Northwind Labs $8K, AtlasGrid $6K), while cloud hosting costs increased $6.4K to $35.5K due entirely to higher AWS usage. The top three drivers account for 81.8% of the revenue lift, highlighting concentration risk.</a:t>
+              <a:t>DemoCo posted a strong August: subscription revenue rose $33K (22%) to $183K, driven by four customers—Meridian Health (+$10K), SMB Bulk (+$9K), Northwind Labs (+$8K), and AtlasGrid (+$6K)—with the top three contributing 81.8% of the gain. Cloud hosting expense increased $6.4K (22%) to $35.5K, entirely due to higher AWS usage, representing 100% of the cost increase. Concentration risk remains elevated, and limited historical data precludes statistical significance testing.</a:t>
             </a:r>
           </a:p>
           <a:p/>
           <a:p>
             <a:r>
-              <a:t>Risks: The subscription revenue increase is highly concentrated: 81.8% of the lift comes from the top three customers, raising reliance risk.; Statistical significance cannot be assessed due to insufficient historical data for both revenue and hosting variances.</a:t>
+              <a:t>Risks: Subscription revenue increase is highly concentrated: the top three customers represent 81.8% of the gain.; Cloud hosting cost increase is fully attributable to AWS, indicating a single‑vendor exposure.; Insufficient historical data prevents statistical significance testing for both variances.</a:t>
             </a:r>
           </a:p>
         </p:txBody>
@@ -5010,7 +5323,7 @@
                 </a:solidFill>
                 <a:latin typeface="Calibri"/>
               </a:rPr>
-              <a:t>Subscription revenue jumped $33K MoM, driven by four key accounts; cloud hosting costs rose $6.4K due to AWS.</a:t>
+              <a:t>Subscription revenue up $33K (22%) and cloud hosting expense up $6.4K (22%) in August</a:t>
             </a:r>
           </a:p>
         </p:txBody>
@@ -5748,7 +6061,7 @@
                 </a:solidFill>
                 <a:latin typeface="Calibri"/>
               </a:rPr>
-              <a:t>Prepared for leadership and partner teams  |  Run run_a11afc9dbb3f  |  Every figure traced to source transactions</a:t>
+              <a:t>Prepared for leadership and partner teams  |  Run run_4fd778726cd1  |  Every figure traced to source transactions</a:t>
             </a:r>
           </a:p>
         </p:txBody>
@@ -5988,7 +6301,7 @@
                 </a:solidFill>
                 <a:latin typeface="Calibri"/>
               </a:rPr>
-              <a:t>Ledgerlight  |  DemoCo  |  2026-07 to 2026-08  |  Run run_a11afc9dbb3f</a:t>
+              <a:t>Ledgerlight  |  DemoCo  |  2026-07 to 2026-08  |  Run run_4fd778726cd1</a:t>
             </a:r>
           </a:p>
         </p:txBody>
@@ -8290,7 +8603,7 @@
                 </a:solidFill>
                 <a:latin typeface="Calibri"/>
               </a:rPr>
-              <a:t>Ledgerlight  |  DemoCo  |  2026-07 to 2026-08  |  Run run_a11afc9dbb3f</a:t>
+              <a:t>Ledgerlight  |  DemoCo  |  2026-07 to 2026-08  |  Run run_4fd778726cd1</a:t>
             </a:r>
           </a:p>
         </p:txBody>
@@ -8346,7 +8659,7 @@
         <p:spPr>
           <a:xfrm>
             <a:off x="548640" y="1645920"/>
-            <a:ext cx="7772400" cy="4572000"/>
+            <a:ext cx="6766560" cy="4572000"/>
           </a:xfrm>
           <a:prstGeom prst="rect">
             <a:avLst/>
@@ -8393,7 +8706,7 @@
         </p:nvGraphicFramePr>
         <p:xfrm>
           <a:off x="640080" y="1737360"/>
-          <a:ext cx="7589520" cy="4114800"/>
+          <a:ext cx="6583680" cy="4114800"/>
         </p:xfrm>
         <a:graphic>
           <a:graphicData uri="http://schemas.openxmlformats.org/drawingml/2006/chart">
@@ -8410,7 +8723,7 @@
         <p:spPr>
           <a:xfrm>
             <a:off x="777240" y="5916168"/>
-            <a:ext cx="7315200" cy="228600"/>
+            <a:ext cx="6400800" cy="228600"/>
           </a:xfrm>
           <a:prstGeom prst="rect">
             <a:avLst/>
@@ -8438,7 +8751,7 @@
                 </a:solidFill>
                 <a:latin typeface="Calibri"/>
               </a:rPr>
-              <a:t>Green adds revenue, red reduces it. Vertical axis is truncated to make the movements visible.</a:t>
+              <a:t>Green adds revenue, red reduces it. % is each driver against opening revenue. Axis truncated.</a:t>
             </a:r>
           </a:p>
         </p:txBody>
@@ -8451,8 +8764,8 @@
         </p:nvSpPr>
         <p:spPr>
           <a:xfrm>
-            <a:off x="8595360" y="1645920"/>
-            <a:ext cx="3047695" cy="274320"/>
+            <a:off x="7589520" y="1645920"/>
+            <a:ext cx="4053535" cy="274320"/>
           </a:xfrm>
           <a:prstGeom prst="rect">
             <a:avLst/>
@@ -8480,7 +8793,7 @@
                 </a:solidFill>
                 <a:latin typeface="Calibri"/>
               </a:rPr>
-              <a:t>How to read it</a:t>
+              <a:t>Share of revenue movement</a:t>
             </a:r>
           </a:p>
         </p:txBody>
@@ -8493,7 +8806,7 @@
         </p:nvSpPr>
         <p:spPr>
           <a:xfrm>
-            <a:off x="8595360" y="1938528"/>
+            <a:off x="7589520" y="1938528"/>
             <a:ext cx="457200" cy="25400"/>
           </a:xfrm>
           <a:prstGeom prst="rect">
@@ -8531,106 +8844,14 @@
       </p:sp>
       <p:sp>
         <p:nvSpPr>
-          <p:cNvPr id="13" name="TextBox 12"/>
-          <p:cNvSpPr txBox="1"/>
-          <p:nvPr/>
-        </p:nvSpPr>
-        <p:spPr>
-          <a:xfrm>
-            <a:off x="8595360" y="2103120"/>
-            <a:ext cx="3047695" cy="2743200"/>
-          </a:xfrm>
-          <a:prstGeom prst="rect">
-            <a:avLst/>
-          </a:prstGeom>
-          <a:noFill/>
-        </p:spPr>
-        <p:txBody>
-          <a:bodyPr wrap="square" anchor="t" lIns="0" rIns="0" tIns="0" bIns="0">
-            <a:spAutoFit/>
-          </a:bodyPr>
-          <a:lstStyle/>
-          <a:p>
-            <a:pPr algn="l" marL="182880" indent="-182880">
-              <a:lnSpc>
-                <a:spcPct val="105000"/>
-              </a:lnSpc>
-              <a:spcAft>
-                <a:spcPts val="800"/>
-              </a:spcAft>
-              <a:buClr>
-                <a:srgbClr val="2BB3A3"/>
-              </a:buClr>
-              <a:buChar char="•"/>
-            </a:pPr>
-            <a:r>
-              <a:rPr sz="1300" b="0">
-                <a:solidFill>
-                  <a:srgbClr val="E6EDF5"/>
-                </a:solidFill>
-                <a:latin typeface="Calibri"/>
-              </a:rPr>
-              <a:t>Starts at $150K in 2026-07 and ends at $183K in 2026-08.</a:t>
-            </a:r>
-          </a:p>
-          <a:p>
-            <a:pPr algn="l" marL="182880" indent="-182880">
-              <a:lnSpc>
-                <a:spcPct val="105000"/>
-              </a:lnSpc>
-              <a:spcAft>
-                <a:spcPts val="800"/>
-              </a:spcAft>
-              <a:buClr>
-                <a:srgbClr val="2BB3A3"/>
-              </a:buClr>
-              <a:buChar char="•"/>
-            </a:pPr>
-            <a:r>
-              <a:rPr sz="1300" b="0">
-                <a:solidFill>
-                  <a:srgbClr val="E6EDF5"/>
-                </a:solidFill>
-                <a:latin typeface="Calibri"/>
-              </a:rPr>
-              <a:t>Biggest lift: Meridian Health, +$10K.</a:t>
-            </a:r>
-          </a:p>
-          <a:p>
-            <a:pPr algn="l" marL="182880" indent="-182880">
-              <a:lnSpc>
-                <a:spcPct val="105000"/>
-              </a:lnSpc>
-              <a:spcAft>
-                <a:spcPts val="800"/>
-              </a:spcAft>
-              <a:buClr>
-                <a:srgbClr val="2BB3A3"/>
-              </a:buClr>
-              <a:buChar char="•"/>
-            </a:pPr>
-            <a:r>
-              <a:rPr sz="1300" b="0">
-                <a:solidFill>
-                  <a:srgbClr val="E6EDF5"/>
-                </a:solidFill>
-                <a:latin typeface="Calibri"/>
-              </a:rPr>
-              <a:t>Drivers fully explain the movement; no unattributed remainder.</a:t>
-            </a:r>
-          </a:p>
-        </p:txBody>
-      </p:sp>
-      <p:sp>
-        <p:nvSpPr>
-          <p:cNvPr id="14" name="Rectangle 13"/>
+          <p:cNvPr id="13" name="Rectangle 12"/>
           <p:cNvSpPr/>
           <p:nvPr/>
         </p:nvSpPr>
         <p:spPr>
           <a:xfrm>
-            <a:off x="8595360" y="4937760"/>
-            <a:ext cx="3047695" cy="1280160"/>
+            <a:off x="7589520" y="2057400"/>
+            <a:ext cx="4053535" cy="2743200"/>
           </a:xfrm>
           <a:prstGeom prst="rect">
             <a:avLst/>
@@ -8667,16 +8888,80 @@
           </a:p>
         </p:txBody>
       </p:sp>
-      <p:sp>
-        <p:nvSpPr>
-          <p:cNvPr id="15" name="TextBox 14"/>
+      <p:graphicFrame>
+        <p:nvGraphicFramePr>
+          <p:cNvPr id="14" name="Chart 13"/>
+          <p:cNvGraphicFramePr>
+            <a:graphicFrameLocks noGrp="1"/>
+          </p:cNvGraphicFramePr>
+          <p:nvPr/>
+        </p:nvGraphicFramePr>
+        <p:xfrm>
+          <a:off x="7635240" y="2103120"/>
+          <a:ext cx="3962095" cy="2651760"/>
+        </p:xfrm>
+        <a:graphic>
+          <a:graphicData uri="http://schemas.openxmlformats.org/drawingml/2006/chart">
+            <c:chart xmlns:c="http://schemas.openxmlformats.org/drawingml/2006/chart" r:id="rId3"/>
+          </a:graphicData>
+        </a:graphic>
+      </p:graphicFrame>
+      <p:sp>
+        <p:nvSpPr>
+          <p:cNvPr id="15" name="Rectangle 14"/>
+          <p:cNvSpPr/>
+          <p:nvPr/>
+        </p:nvSpPr>
+        <p:spPr>
+          <a:xfrm>
+            <a:off x="7589520" y="4937760"/>
+            <a:ext cx="4053535" cy="1280160"/>
+          </a:xfrm>
+          <a:prstGeom prst="rect">
+            <a:avLst/>
+          </a:prstGeom>
+          <a:solidFill>
+            <a:srgbClr val="16212E"/>
+          </a:solidFill>
+          <a:ln w="9525">
+            <a:solidFill>
+              <a:srgbClr val="26364A"/>
+            </a:solidFill>
+          </a:ln>
+          <a:effectLst/>
+        </p:spPr>
+        <p:style>
+          <a:lnRef idx="1">
+            <a:schemeClr val="accent1"/>
+          </a:lnRef>
+          <a:fillRef idx="3">
+            <a:schemeClr val="accent1"/>
+          </a:fillRef>
+          <a:effectRef idx="2">
+            <a:schemeClr val="accent1"/>
+          </a:effectRef>
+          <a:fontRef idx="minor">
+            <a:schemeClr val="lt1"/>
+          </a:fontRef>
+        </p:style>
+        <p:txBody>
+          <a:bodyPr rtlCol="0" anchor="ctr"/>
+          <a:lstStyle/>
+          <a:p>
+            <a:pPr algn="ctr"/>
+          </a:p>
+        </p:txBody>
+      </p:sp>
+      <p:sp>
+        <p:nvSpPr>
+          <p:cNvPr id="16" name="TextBox 15"/>
           <p:cNvSpPr txBox="1"/>
           <p:nvPr/>
         </p:nvSpPr>
         <p:spPr>
           <a:xfrm>
-            <a:off x="8778240" y="5047488"/>
-            <a:ext cx="2681935" cy="274320"/>
+            <a:off x="7772400" y="5047488"/>
+            <a:ext cx="3687775" cy="274320"/>
           </a:xfrm>
           <a:prstGeom prst="rect">
             <a:avLst/>
@@ -8711,14 +8996,14 @@
       </p:sp>
       <p:sp>
         <p:nvSpPr>
-          <p:cNvPr id="16" name="TextBox 15"/>
+          <p:cNvPr id="17" name="TextBox 16"/>
           <p:cNvSpPr txBox="1"/>
           <p:nvPr/>
         </p:nvSpPr>
         <p:spPr>
           <a:xfrm>
-            <a:off x="8778240" y="5321808"/>
-            <a:ext cx="2681935" cy="822960"/>
+            <a:off x="7772400" y="5321808"/>
+            <a:ext cx="3687775" cy="822960"/>
           </a:xfrm>
           <a:prstGeom prst="rect">
             <a:avLst/>
@@ -8746,7 +9031,7 @@
                 </a:solidFill>
                 <a:latin typeface="Calibri"/>
               </a:rPr>
-              <a:t>4 drivers added revenue and 0 reduced it; the net effect is +$33K.</a:t>
+              <a:t>Meridian Health is 30% of the movement; net effect +$33K from 4 drivers.</a:t>
             </a:r>
           </a:p>
         </p:txBody>
@@ -8986,7 +9271,7 @@
                 </a:solidFill>
                 <a:latin typeface="Calibri"/>
               </a:rPr>
-              <a:t>Ledgerlight  |  DemoCo  |  2026-07 to 2026-08  |  Run run_a11afc9dbb3f</a:t>
+              <a:t>Ledgerlight  |  DemoCo  |  2026-07 to 2026-08  |  Run run_4fd778726cd1</a:t>
             </a:r>
           </a:p>
         </p:txBody>
@@ -9285,7 +9570,7 @@
           <a:graphicData uri="http://schemas.openxmlformats.org/drawingml/2006/table">
             <a:tbl>
               <a:tblPr firstRow="0" bandRow="0">
-                <a:tableStyleId>{5C22544A-7EE6-4342-B048-85BDC9FD1C3A}</a:tableStyleId>
+                <a:tableStyleId>{2D5ABB26-0587-4C30-8999-92F81FD0307C}</a:tableStyleId>
               </a:tblPr>
               <a:tblGrid>
                 <a:gridCol w="1472892"/>
@@ -10590,7 +10875,7 @@
                 </a:solidFill>
                 <a:latin typeface="Calibri"/>
               </a:rPr>
-              <a:t>Ledgerlight  |  DemoCo  |  2026-07 to 2026-08  |  Run run_a11afc9dbb3f</a:t>
+              <a:t>Ledgerlight  |  DemoCo  |  2026-07 to 2026-08  |  Run run_4fd778726cd1</a:t>
             </a:r>
           </a:p>
         </p:txBody>
@@ -11154,7 +11439,7 @@
                 </a:solidFill>
                 <a:latin typeface="Calibri"/>
               </a:rPr>
-              <a:t>10/10</a:t>
+              <a:t>16/16</a:t>
             </a:r>
           </a:p>
         </p:txBody>
@@ -11919,7 +12204,7 @@
                 </a:solidFill>
                 <a:latin typeface="Calibri"/>
               </a:rPr>
-              <a:t>Ledgerlight  |  DemoCo  |  2026-07 to 2026-08  |  Run run_a11afc9dbb3f</a:t>
+              <a:t>Ledgerlight  |  DemoCo  |  2026-07 to 2026-08  |  Run run_4fd778726cd1</a:t>
             </a:r>
           </a:p>
         </p:txBody>
@@ -12559,7 +12844,7 @@
                 </a:solidFill>
                 <a:latin typeface="Calibri"/>
               </a:rPr>
-              <a:t>The explanation is evidence-backed: 10/10 numbers verified, data quality 100%.</a:t>
+              <a:t>The explanation is evidence-backed: 16/16 numbers verified, data quality 100%.</a:t>
             </a:r>
           </a:p>
         </p:txBody>
@@ -12737,7 +13022,7 @@
                 </a:solidFill>
                 <a:latin typeface="Calibri"/>
               </a:rPr>
-              <a:t>The subscription revenue increase is highly concentrated: 81.8% of the lift comes from the top three customers, raising reliance risk.</a:t>
+              <a:t>Subscription revenue increase is highly concentrated: the top three customers represent 81.8% of the gain.</a:t>
             </a:r>
           </a:p>
           <a:p>
@@ -12760,7 +13045,30 @@
                 </a:solidFill>
                 <a:latin typeface="Calibri"/>
               </a:rPr>
-              <a:t>Statistical significance cannot be assessed due to insufficient historical data for both revenue and hosting variances.</a:t>
+              <a:t>Cloud hosting cost increase is fully attributable to AWS, indicating a single‑vendor exposure.</a:t>
+            </a:r>
+          </a:p>
+          <a:p>
+            <a:pPr algn="l" marL="182880" indent="-182880">
+              <a:lnSpc>
+                <a:spcPct val="100000"/>
+              </a:lnSpc>
+              <a:spcAft>
+                <a:spcPts val="700"/>
+              </a:spcAft>
+              <a:buClr>
+                <a:srgbClr val="2BB3A3"/>
+              </a:buClr>
+              <a:buChar char="•"/>
+            </a:pPr>
+            <a:r>
+              <a:rPr sz="1200" b="0">
+                <a:solidFill>
+                  <a:srgbClr val="E6EDF5"/>
+                </a:solidFill>
+                <a:latin typeface="Calibri"/>
+              </a:rPr>
+              <a:t>Insufficient historical data prevents statistical significance testing for both variances.</a:t>
             </a:r>
           </a:p>
         </p:txBody>
@@ -12884,13 +13192,13 @@
               </a:spcAft>
             </a:pPr>
             <a:r>
-              <a:rPr sz="1350" b="0">
+              <a:rPr sz="1250" b="0">
                 <a:solidFill>
                   <a:srgbClr val="E6EDF5"/>
                 </a:solidFill>
                 <a:latin typeface="Calibri"/>
               </a:rPr>
-              <a:t>DemoCo's subscription revenue rose $33K MoM to $183K, driven by four key accounts (Meridian Health $10K, SMB Bulk $9K, Northwind Labs $8K, AtlasGrid $6K), while cloud hosting costs increased $6.4K to $35.5K due entirely to higher…</a:t>
+              <a:t>DemoCo posted a strong August: subscription revenue rose $33K (22%) to $183K, driven by four customers—Meridian Health (+$10K), SMB Bulk (+$9K), Northwind Labs (+$8K), and AtlasGrid (+$6K)—with the top three contributing 81.8% of the gain. Cloud hosting expense increased $6.4K (22%) to $35.5K, entirely due to higher AWS usage,…</a:t>
             </a:r>
           </a:p>
         </p:txBody>
@@ -13130,7 +13438,7 @@
                 </a:solidFill>
                 <a:latin typeface="Calibri"/>
               </a:rPr>
-              <a:t>Ledgerlight  |  DemoCo  |  2026-07 to 2026-08  |  Run run_a11afc9dbb3f</a:t>
+              <a:t>Ledgerlight  |  DemoCo  |  2026-07 to 2026-08  |  Run run_4fd778726cd1</a:t>
             </a:r>
           </a:p>
         </p:txBody>
@@ -13350,7 +13658,7 @@
                 </a:solidFill>
                 <a:latin typeface="Calibri"/>
               </a:rPr>
-              <a:t>Are there any upcoming contract renewals or expansions with Meridian Health, SMB Bulk, Northwind Labs, o…</a:t>
+              <a:t>Is the growth from Meridian Health, SMB Bulk, Northwind Labs, and AtlasGrid expected to continue in the…</a:t>
             </a:r>
           </a:p>
           <a:p>
@@ -13373,7 +13681,7 @@
                 </a:solidFill>
                 <a:latin typeface="Calibri"/>
               </a:rPr>
-              <a:t>What is the expected AWS usage trend for the next periods, and are there any cost‑optimization initiativ…</a:t>
+              <a:t>Are there plans to diversify the customer base to reduce concentration risk?</a:t>
             </a:r>
           </a:p>
           <a:p>
@@ -13396,7 +13704,7 @@
                 </a:solidFill>
                 <a:latin typeface="Calibri"/>
               </a:rPr>
-              <a:t>Do we have visibility into churn or downgrade risk among these top contributors?</a:t>
+              <a:t>Will AWS usage patterns change, and are there cost‑optimization initiatives in place?</a:t>
             </a:r>
           </a:p>
         </p:txBody>

</xml_diff>